<commit_message>
docs: incorporate verified public repository URL into presentation and comprehensive proposal
</commit_message>
<xml_diff>
--- a/docs/RailSahayak_Stakeholder_Presentation.pptx
+++ b/docs/RailSahayak_Stakeholder_Presentation.pptx
@@ -3647,7 +3647,7 @@
               </a:defRPr>
             </a:pPr>
             <a:r>
-              <a:t>Independent technical exploration prototype  |  October 2026  |  No official endorsement claimed</a:t>
+              <a:t>Independent technical exploration prototype  |  October 2026  |  Repository: github.com/rajivsharma8757/RailSahayak</a:t>
             </a:r>
           </a:p>
         </p:txBody>
@@ -4247,7 +4247,7 @@
               </a:defRPr>
             </a:pPr>
             <a:r>
-              <a:t>1. Review the current prototype and its evidence.</a:t>
+              <a:t>1. Review the current prototype and its evidence (Repository: github.com/rajivsharma8757/RailSahayak).</a:t>
             </a:r>
             <a:br/>
             <a:r>
@@ -4648,7 +4648,7 @@
             </a:r>
             <a:br/>
             <a:r>
-              <a:t>Project materials and technical evidence can be prepared for review.</a:t>
+              <a:t>Public Repository: https://github.com/rajivsharma8757/RailSahayak</a:t>
             </a:r>
             <a:br/>
             <a:r>

</xml_diff>

<commit_message>
docs: finalize multi-organization stakeholder outreach package, recipient directory, and live demo documentation
</commit_message>
<xml_diff>
--- a/docs/RailSahayak_Stakeholder_Presentation.pptx
+++ b/docs/RailSahayak_Stakeholder_Presentation.pptx
@@ -3647,7 +3647,7 @@
               </a:defRPr>
             </a:pPr>
             <a:r>
-              <a:t>Independent technical exploration prototype  |  October 2026  |  Repository: github.com/rajivsharma8757/RailSahayak</a:t>
+              <a:t>Independent technical exploration prototype  |  October 2026  |  Demo: railsahayak-backend.onrender.com  |  Repo: github.com/rajivsharma8757/RailSahayak</a:t>
             </a:r>
           </a:p>
         </p:txBody>
@@ -4247,7 +4247,7 @@
               </a:defRPr>
             </a:pPr>
             <a:r>
-              <a:t>1. Review the current prototype and its evidence (Repository: github.com/rajivsharma8757/RailSahayak).</a:t>
+              <a:t>1. Review the current prototype and its evidence (Demo: railsahayak-backend.onrender.com | Repo: github.com/rajivsharma8757/RailSahayak).</a:t>
             </a:r>
             <a:br/>
             <a:r>
@@ -4589,8 +4589,8 @@
         </p:nvSpPr>
         <p:spPr>
           <a:xfrm>
-            <a:off x="731520" y="4892040"/>
-            <a:ext cx="5120640" cy="1234440"/>
+            <a:off x="731520" y="4800600"/>
+            <a:ext cx="5120640" cy="1371600"/>
           </a:xfrm>
           <a:prstGeom prst="roundRect">
             <a:avLst/>
@@ -4636,7 +4636,7 @@
           </a:p>
           <a:p>
             <a:pPr>
-              <a:defRPr sz="850">
+              <a:defRPr sz="750">
                 <a:solidFill>
                   <a:srgbClr val="1E293B"/>
                 </a:solidFill>
@@ -4648,11 +4648,15 @@
             </a:r>
             <a:br/>
             <a:r>
-              <a:t>Public Repository: https://github.com/rajivsharma8757/RailSahayak</a:t>
+              <a:t>Developer: Rajiv Sharma (3rd-Yr B.Tech CSE, MMDU Mullana)</a:t>
             </a:r>
             <a:br/>
             <a:r>
-              <a:t>October 2026</a:t>
+              <a:t>Live Demo: https://railsahayak-backend.onrender.com</a:t>
+            </a:r>
+            <a:br/>
+            <a:r>
+              <a:t>Repo: https://github.com/rajivsharma8757/RailSahayak | rajivkumarsharma200@gmail.com</a:t>
             </a:r>
           </a:p>
         </p:txBody>

</xml_diff>